<commit_message>
feat: Regenerate presentation deck keeping original orange theme and logos
</commit_message>
<xml_diff>
--- a/Presentation_PPt.pptx
+++ b/Presentation_PPt.pptx
@@ -10,6 +10,11 @@
     <p:sldId id="258" r:id="rId4"/>
     <p:sldId id="259" r:id="rId5"/>
     <p:sldId id="260" r:id="rId6"/>
+    <p:sldId id="262" r:id="rId11"/>
+    <p:sldId id="263" r:id="rId12"/>
+    <p:sldId id="264" r:id="rId13"/>
+    <p:sldId id="265" r:id="rId14"/>
+    <p:sldId id="266" r:id="rId15"/>
   </p:sldIdLst>
   <p:sldSz cx="12192000" cy="6858000"/>
   <p:notesSz cx="6858000" cy="9144000"/>
@@ -3842,47 +3847,60 @@
           </a:bodyPr>
           <a:lstStyle/>
           <a:p>
+            <a:pPr>
+              <a:spcAft>
+                <a:spcPts val="1200"/>
+              </a:spcAft>
+              <a:defRPr sz="3200" b="1">
+                <a:solidFill>
+                  <a:srgbClr val="E48312"/>
+                </a:solidFill>
+                <a:latin typeface="Times New Roman"/>
+              </a:defRPr>
+              <a:buNone/>
+            </a:pPr>
+            <a:r>
+              <a:t>Project Title: AlignMate</a:t>
+            </a:r>
             <a:endParaRPr lang="en-IN" dirty="0"/>
           </a:p>
           <a:p>
-            <a:r>
-              <a:rPr lang="en-IN" sz="2800" b="1" dirty="0">
-                <a:latin typeface="Times New Roman" panose="02020603050405020304" pitchFamily="18" charset="0"/>
-                <a:cs typeface="Times New Roman" panose="02020603050405020304" pitchFamily="18" charset="0"/>
-              </a:rPr>
-              <a:t>Project Title:</a:t>
-            </a:r>
-            <a:br>
-              <a:rPr lang="en-IN" sz="2800" b="1" dirty="0">
-                <a:latin typeface="Times New Roman" panose="02020603050405020304" pitchFamily="18" charset="0"/>
-                <a:cs typeface="Times New Roman" panose="02020603050405020304" pitchFamily="18" charset="0"/>
-              </a:rPr>
-            </a:br>
-            <a:endParaRPr lang="en-IN" sz="2800" b="1" dirty="0">
-              <a:latin typeface="Times New Roman" panose="02020603050405020304" pitchFamily="18" charset="0"/>
-              <a:cs typeface="Times New Roman" panose="02020603050405020304" pitchFamily="18" charset="0"/>
-            </a:endParaRPr>
-          </a:p>
-          <a:p>
-            <a:endParaRPr lang="en-IN" sz="2800" b="1" dirty="0">
-              <a:latin typeface="Times New Roman" panose="02020603050405020304" pitchFamily="18" charset="0"/>
-              <a:cs typeface="Times New Roman" panose="02020603050405020304" pitchFamily="18" charset="0"/>
-            </a:endParaRPr>
-          </a:p>
-          <a:p>
-            <a:endParaRPr lang="en-IN" sz="2800" b="1" dirty="0">
-              <a:latin typeface="Times New Roman" panose="02020603050405020304" pitchFamily="18" charset="0"/>
-              <a:cs typeface="Times New Roman" panose="02020603050405020304" pitchFamily="18" charset="0"/>
-            </a:endParaRPr>
-          </a:p>
-          <a:p>
-            <a:pPr algn="r"/>
-            <a:r>
-              <a:rPr lang="en-IN" sz="2800" b="1" dirty="0">
-                <a:latin typeface="Times New Roman" panose="02020603050405020304" pitchFamily="18" charset="0"/>
-                <a:cs typeface="Times New Roman" panose="02020603050405020304" pitchFamily="18" charset="0"/>
-              </a:rPr>
-              <a:t>Submitted By:</a:t>
+            <a:pPr>
+              <a:spcAft>
+                <a:spcPts val="4000"/>
+              </a:spcAft>
+              <a:defRPr sz="1800">
+                <a:solidFill>
+                  <a:srgbClr val="505050"/>
+                </a:solidFill>
+                <a:latin typeface="Times New Roman"/>
+              </a:defRPr>
+              <a:buNone/>
+            </a:pPr>
+            <a:r>
+              <a:t>AI-Powered Real-Time Posture Coach &amp; Fitness Companion</a:t>
+            </a:r>
+          </a:p>
+          <a:p>
+            <a:pPr>
+              <a:spcAft>
+                <a:spcPts val="2000"/>
+              </a:spcAft>
+              <a:buNone/>
+            </a:pPr>
+          </a:p>
+          <a:p>
+            <a:pPr>
+              <a:defRPr sz="1800" b="1">
+                <a:solidFill>
+                  <a:srgbClr val="1C1C1C"/>
+                </a:solidFill>
+                <a:latin typeface="Times New Roman"/>
+              </a:defRPr>
+              <a:buNone/>
+            </a:pPr>
+            <a:r>
+              <a:t>Submitted By: Arjun Bhati &amp; Team</a:t>
             </a:r>
           </a:p>
         </p:txBody>
@@ -3930,6 +3948,162 @@
 </p:sld>
 </file>
 
+<file path=ppt/slides/slide10.xml><?xml version="1.0" encoding="utf-8"?>
+<p:sld xmlns:a="http://schemas.openxmlformats.org/drawingml/2006/main" xmlns:p="http://schemas.openxmlformats.org/presentationml/2006/main" xmlns:r="http://schemas.openxmlformats.org/officeDocument/2006/relationships">
+  <p:cSld>
+    <p:spTree>
+      <p:nvGrpSpPr>
+        <p:cNvPr id="1" name=""/>
+        <p:cNvGrpSpPr/>
+        <p:nvPr/>
+      </p:nvGrpSpPr>
+      <p:grpSpPr/>
+      <p:sp>
+        <p:nvSpPr>
+          <p:cNvPr id="2" name="Title 1"/>
+          <p:cNvSpPr>
+            <a:spLocks noGrp="1"/>
+          </p:cNvSpPr>
+          <p:nvPr>
+            <p:ph type="title"/>
+          </p:nvPr>
+        </p:nvSpPr>
+        <p:spPr/>
+        <p:txBody>
+          <a:bodyPr/>
+          <a:lstStyle/>
+          <a:p/>
+        </p:txBody>
+      </p:sp>
+      <p:sp>
+        <p:nvSpPr>
+          <p:cNvPr id="3" name="Content Placeholder 2"/>
+          <p:cNvSpPr>
+            <a:spLocks noGrp="1"/>
+          </p:cNvSpPr>
+          <p:nvPr>
+            <p:ph idx="1"/>
+          </p:nvPr>
+        </p:nvSpPr>
+        <p:spPr/>
+        <p:txBody>
+          <a:bodyPr wrap="square"/>
+          <a:lstStyle/>
+          <a:p>
+            <a:pPr>
+              <a:spcAft>
+                <a:spcPts val="1600"/>
+              </a:spcAft>
+              <a:defRPr sz="2400" b="1">
+                <a:solidFill>
+                  <a:srgbClr val="E48312"/>
+                </a:solidFill>
+                <a:latin typeface="Times New Roman"/>
+              </a:defRPr>
+              <a:buNone/>
+            </a:pPr>
+            <a:r>
+              <a:t>Technical Debugging &amp; Future Roadmap</a:t>
+            </a:r>
+          </a:p>
+          <a:p>
+            <a:pPr>
+              <a:spcAft>
+                <a:spcPts val="800"/>
+              </a:spcAft>
+              <a:defRPr sz="1400">
+                <a:solidFill>
+                  <a:srgbClr val="1C1C1C"/>
+                </a:solidFill>
+                <a:latin typeface="Times New Roman"/>
+              </a:defRPr>
+            </a:pPr>
+            <a:r>
+              <a:t>Network Latency Fix: Reduced lag from 500ms to &lt;15ms by streaming coordinate floats instead of video frames.</a:t>
+            </a:r>
+          </a:p>
+          <a:p>
+            <a:pPr>
+              <a:spcAft>
+                <a:spcPts val="800"/>
+              </a:spcAft>
+              <a:defRPr sz="1400">
+                <a:solidFill>
+                  <a:srgbClr val="1C1C1C"/>
+                </a:solidFill>
+                <a:latin typeface="Times New Roman"/>
+              </a:defRPr>
+            </a:pPr>
+            <a:r>
+              <a:t>OOM Crash Prevention: Migrated from heavy local Ollama model to Google Gemini API, saving 75% server RAM.</a:t>
+            </a:r>
+          </a:p>
+          <a:p>
+            <a:pPr>
+              <a:spcAft>
+                <a:spcPts val="800"/>
+              </a:spcAft>
+              <a:defRPr sz="1400">
+                <a:solidFill>
+                  <a:srgbClr val="1C1C1C"/>
+                </a:solidFill>
+                <a:latin typeface="Times New Roman"/>
+              </a:defRPr>
+            </a:pPr>
+            <a:r>
+              <a:t>Database Pool Scoping: Resolved SQL connection exhaustion by integrating scoped database session dependency injection.</a:t>
+            </a:r>
+          </a:p>
+          <a:p>
+            <a:pPr>
+              <a:spcAft>
+                <a:spcPts val="800"/>
+              </a:spcAft>
+              <a:defRPr sz="1400">
+                <a:solidFill>
+                  <a:srgbClr val="1C1C1C"/>
+                </a:solidFill>
+                <a:latin typeface="Times New Roman"/>
+              </a:defRPr>
+            </a:pPr>
+            <a:r>
+              <a:t>Mobile App Expansion: Future roadmap includes React Native mobile client using MoveNet on-device posture tracking.</a:t>
+            </a:r>
+          </a:p>
+        </p:txBody>
+      </p:sp>
+      <p:pic>
+        <p:nvPicPr>
+          <p:cNvPr id="4" name="Picture 3" descr="image.png"/>
+          <p:cNvPicPr>
+            <a:picLocks noChangeAspect="1"/>
+          </p:cNvPicPr>
+          <p:nvPr/>
+        </p:nvPicPr>
+        <p:blipFill>
+          <a:blip r:embed="rId2"/>
+          <a:stretch>
+            <a:fillRect/>
+          </a:stretch>
+        </p:blipFill>
+        <p:spPr>
+          <a:xfrm>
+            <a:off x="1580457" y="210539"/>
+            <a:ext cx="9092045" cy="1158340"/>
+          </a:xfrm>
+          <a:prstGeom prst="rect">
+            <a:avLst/>
+          </a:prstGeom>
+        </p:spPr>
+      </p:pic>
+    </p:spTree>
+  </p:cSld>
+  <p:clrMapOvr>
+    <a:masterClrMapping/>
+  </p:clrMapOvr>
+</p:sld>
+</file>
+
 <file path=ppt/slides/slide2.xml><?xml version="1.0" encoding="utf-8"?>
 <p:sld xmlns:a="http://schemas.openxmlformats.org/drawingml/2006/main" xmlns:r="http://schemas.openxmlformats.org/officeDocument/2006/relationships" xmlns:p="http://schemas.openxmlformats.org/presentationml/2006/main">
   <p:cSld>
@@ -3970,66 +4144,186 @@
           </a:xfrm>
         </p:spPr>
         <p:txBody>
-          <a:bodyPr>
+          <a:bodyPr wrap="square">
             <a:normAutofit lnSpcReduction="10000"/>
           </a:bodyPr>
           <a:lstStyle/>
           <a:p>
-            <a:r>
-              <a:rPr lang="en-IN" b="1" dirty="0"/>
-              <a:t>Slide 1: Title &amp; Project Abstract</a:t>
-            </a:r>
-          </a:p>
-          <a:p>
-            <a:r>
-              <a:rPr lang="en-IN" b="1" dirty="0"/>
-              <a:t>Slide 2: Problem Statement &amp; Engineering Context</a:t>
-            </a:r>
-          </a:p>
-          <a:p>
-            <a:r>
-              <a:rPr lang="en-IN" b="1" dirty="0"/>
-              <a:t>Slide 3: Pipeline System Architecture</a:t>
-            </a:r>
-          </a:p>
-          <a:p>
-            <a:r>
-              <a:rPr lang="en-IN" b="1" dirty="0"/>
-              <a:t>Slide 4: Data Engineering Pipeline</a:t>
-            </a:r>
-          </a:p>
-          <a:p>
-            <a:r>
-              <a:rPr lang="en-IN" b="1" dirty="0"/>
-              <a:t>Slide 5: Challenges &amp; Solutions</a:t>
-            </a:r>
-          </a:p>
-          <a:p>
-            <a:r>
-              <a:rPr lang="en-IN" b="1" dirty="0"/>
-              <a:t>Slide 6: Containerization &amp; Model Serving</a:t>
-            </a:r>
-          </a:p>
-          <a:p>
-            <a:r>
-              <a:rPr lang="en-IN" b="1" dirty="0"/>
-              <a:t>Slide 7: Monitoring UI &amp; Client Interface</a:t>
-            </a:r>
-          </a:p>
-          <a:p>
-            <a:r>
-              <a:rPr lang="en-IN" b="1" dirty="0"/>
-              <a:t>Slide 8: Core Technical Challenges &amp; Debugging</a:t>
-            </a:r>
-          </a:p>
-          <a:p>
-            <a:r>
-              <a:rPr lang="en-IN" b="1" dirty="0"/>
-              <a:t>Slide 9: Development &amp; Iteration Roadmap</a:t>
-            </a:r>
-          </a:p>
-          <a:p>
-            <a:endParaRPr lang="en-IN" dirty="0"/>
+            <a:pPr>
+              <a:spcAft>
+                <a:spcPts val="1600"/>
+              </a:spcAft>
+              <a:defRPr sz="2400" b="1">
+                <a:solidFill>
+                  <a:srgbClr val="E48312"/>
+                </a:solidFill>
+                <a:latin typeface="Times New Roman"/>
+              </a:defRPr>
+              <a:buNone/>
+            </a:pPr>
+            <a:r>
+              <a:t>Presentation Outline</a:t>
+            </a:r>
+          </a:p>
+          <a:p>
+            <a:pPr>
+              <a:spcAft>
+                <a:spcPts val="800"/>
+              </a:spcAft>
+              <a:defRPr sz="1400">
+                <a:solidFill>
+                  <a:srgbClr val="1C1C1C"/>
+                </a:solidFill>
+                <a:latin typeface="Times New Roman"/>
+              </a:defRPr>
+            </a:pPr>
+            <a:r>
+              <a:t>Slide 1: Project Title &amp; Abstract</a:t>
+            </a:r>
+          </a:p>
+          <a:p>
+            <a:pPr>
+              <a:spcAft>
+                <a:spcPts val="800"/>
+              </a:spcAft>
+              <a:defRPr sz="1400">
+                <a:solidFill>
+                  <a:srgbClr val="1C1C1C"/>
+                </a:solidFill>
+                <a:latin typeface="Times New Roman"/>
+              </a:defRPr>
+            </a:pPr>
+            <a:r>
+              <a:t>Slide 2: Presentation Outline</a:t>
+            </a:r>
+          </a:p>
+          <a:p>
+            <a:pPr>
+              <a:spcAft>
+                <a:spcPts val="800"/>
+              </a:spcAft>
+              <a:defRPr sz="1400">
+                <a:solidFill>
+                  <a:srgbClr val="1C1C1C"/>
+                </a:solidFill>
+                <a:latin typeface="Times New Roman"/>
+              </a:defRPr>
+            </a:pPr>
+            <a:r>
+              <a:t>Slide 3: Problem Statement &amp; Engineering Context</a:t>
+            </a:r>
+          </a:p>
+          <a:p>
+            <a:pPr>
+              <a:spcAft>
+                <a:spcPts val="800"/>
+              </a:spcAft>
+              <a:defRPr sz="1400">
+                <a:solidFill>
+                  <a:srgbClr val="1C1C1C"/>
+                </a:solidFill>
+                <a:latin typeface="Times New Roman"/>
+              </a:defRPr>
+            </a:pPr>
+            <a:r>
+              <a:t>Slide 4: Pipeline System Architecture</a:t>
+            </a:r>
+          </a:p>
+          <a:p>
+            <a:pPr>
+              <a:spcAft>
+                <a:spcPts val="800"/>
+              </a:spcAft>
+              <a:defRPr sz="1400">
+                <a:solidFill>
+                  <a:srgbClr val="1C1C1C"/>
+                </a:solidFill>
+                <a:latin typeface="Times New Roman"/>
+              </a:defRPr>
+            </a:pPr>
+            <a:r>
+              <a:t>Slide 5: Data Engineering Pipeline (Angle Calculations)</a:t>
+            </a:r>
+          </a:p>
+          <a:p>
+            <a:pPr>
+              <a:spcAft>
+                <a:spcPts val="800"/>
+              </a:spcAft>
+              <a:defRPr sz="1400">
+                <a:solidFill>
+                  <a:srgbClr val="1C1C1C"/>
+                </a:solidFill>
+                <a:latin typeface="Times New Roman"/>
+              </a:defRPr>
+            </a:pPr>
+            <a:r>
+              <a:t>Slide 6: Structured Database RAG (Retrieval-Augmented Generation)</a:t>
+            </a:r>
+          </a:p>
+          <a:p>
+            <a:pPr>
+              <a:spcAft>
+                <a:spcPts val="800"/>
+              </a:spcAft>
+              <a:defRPr sz="1400">
+                <a:solidFill>
+                  <a:srgbClr val="1C1C1C"/>
+                </a:solidFill>
+                <a:latin typeface="Times New Roman"/>
+              </a:defRPr>
+            </a:pPr>
+            <a:r>
+              <a:t>Slide 7: Containerization &amp; Isolation (Docker)</a:t>
+            </a:r>
+          </a:p>
+          <a:p>
+            <a:pPr>
+              <a:spcAft>
+                <a:spcPts val="800"/>
+              </a:spcAft>
+              <a:defRPr sz="1400">
+                <a:solidFill>
+                  <a:srgbClr val="1C1C1C"/>
+                </a:solidFill>
+                <a:latin typeface="Times New Roman"/>
+              </a:defRPr>
+            </a:pPr>
+            <a:r>
+              <a:t>Slide 8: Automated CI/CD Pipelines (GitHub Actions)</a:t>
+            </a:r>
+          </a:p>
+          <a:p>
+            <a:pPr>
+              <a:spcAft>
+                <a:spcPts val="800"/>
+              </a:spcAft>
+              <a:defRPr sz="1400">
+                <a:solidFill>
+                  <a:srgbClr val="1C1C1C"/>
+                </a:solidFill>
+                <a:latin typeface="Times New Roman"/>
+              </a:defRPr>
+            </a:pPr>
+            <a:r>
+              <a:t>Slide 9: Monitoring HUD &amp; Client Interface</a:t>
+            </a:r>
+          </a:p>
+          <a:p>
+            <a:pPr>
+              <a:spcAft>
+                <a:spcPts val="800"/>
+              </a:spcAft>
+              <a:defRPr sz="1400">
+                <a:solidFill>
+                  <a:srgbClr val="1C1C1C"/>
+                </a:solidFill>
+                <a:latin typeface="Times New Roman"/>
+              </a:defRPr>
+            </a:pPr>
+            <a:r>
+              <a:t>Slide 10: Technical Debugging &amp; Future Roadmap</a:t>
+            </a:r>
           </a:p>
         </p:txBody>
       </p:sp>
@@ -4122,10 +4416,89 @@
           </a:xfrm>
         </p:spPr>
         <p:txBody>
-          <a:bodyPr/>
+          <a:bodyPr wrap="square"/>
           <a:lstStyle/>
           <a:p>
+            <a:pPr>
+              <a:spcAft>
+                <a:spcPts val="1600"/>
+              </a:spcAft>
+              <a:defRPr sz="2400" b="1">
+                <a:solidFill>
+                  <a:srgbClr val="E48312"/>
+                </a:solidFill>
+                <a:latin typeface="Times New Roman"/>
+              </a:defRPr>
+              <a:buNone/>
+            </a:pPr>
+            <a:r>
+              <a:t>Problem Statement &amp; Engineering Context</a:t>
+            </a:r>
             <a:endParaRPr lang="en-IN" dirty="0"/>
+          </a:p>
+          <a:p>
+            <a:pPr>
+              <a:spcAft>
+                <a:spcPts val="800"/>
+              </a:spcAft>
+              <a:defRPr sz="1400">
+                <a:solidFill>
+                  <a:srgbClr val="1C1C1C"/>
+                </a:solidFill>
+                <a:latin typeface="Times New Roman"/>
+              </a:defRPr>
+            </a:pPr>
+            <a:r>
+              <a:t>Sedentary Lifestyles: Proved to cause chronic cervical pain, spinal stress, and long-term posture defects.</a:t>
+            </a:r>
+          </a:p>
+          <a:p>
+            <a:pPr>
+              <a:spcAft>
+                <a:spcPts val="800"/>
+              </a:spcAft>
+              <a:defRPr sz="1400">
+                <a:solidFill>
+                  <a:srgbClr val="1C1C1C"/>
+                </a:solidFill>
+                <a:latin typeface="Times New Roman"/>
+              </a:defRPr>
+            </a:pPr>
+            <a:r>
+              <a:t>Exercise Injuries: Lack of real-time form correction leads to acute gym injuries under high loading.</a:t>
+            </a:r>
+          </a:p>
+          <a:p>
+            <a:pPr>
+              <a:spcAft>
+                <a:spcPts val="800"/>
+              </a:spcAft>
+              <a:defRPr sz="1400">
+                <a:solidFill>
+                  <a:srgbClr val="1C1C1C"/>
+                </a:solidFill>
+                <a:latin typeface="Times New Roman"/>
+              </a:defRPr>
+            </a:pPr>
+            <a:r>
+              <a:t>Engineering Constraints: Must perform skeletal tracking at &gt;15 FPS within a standard 2GB server footprint.</a:t>
+            </a:r>
+          </a:p>
+          <a:p>
+            <a:pPr>
+              <a:spcAft>
+                <a:spcPts val="800"/>
+              </a:spcAft>
+              <a:defRPr sz="1400">
+                <a:solidFill>
+                  <a:srgbClr val="1C1C1C"/>
+                </a:solidFill>
+                <a:latin typeface="Times New Roman"/>
+              </a:defRPr>
+            </a:pPr>
+            <a:r>
+              <a:t>User Data Privacy: Zero video streaming or storage in the cloud. Coordinates are processed client-side.</a:t>
+            </a:r>
           </a:p>
         </p:txBody>
       </p:sp>
@@ -4218,10 +4591,89 @@
           </a:xfrm>
         </p:spPr>
         <p:txBody>
-          <a:bodyPr/>
+          <a:bodyPr wrap="square"/>
           <a:lstStyle/>
           <a:p>
+            <a:pPr>
+              <a:spcAft>
+                <a:spcPts val="1600"/>
+              </a:spcAft>
+              <a:defRPr sz="2400" b="1">
+                <a:solidFill>
+                  <a:srgbClr val="E48312"/>
+                </a:solidFill>
+                <a:latin typeface="Times New Roman"/>
+              </a:defRPr>
+              <a:buNone/>
+            </a:pPr>
+            <a:r>
+              <a:t>Pipeline System Architecture</a:t>
+            </a:r>
             <a:endParaRPr lang="en-IN" dirty="0"/>
+          </a:p>
+          <a:p>
+            <a:pPr>
+              <a:spcAft>
+                <a:spcPts val="800"/>
+              </a:spcAft>
+              <a:defRPr sz="1400">
+                <a:solidFill>
+                  <a:srgbClr val="1C1C1C"/>
+                </a:solidFill>
+                <a:latin typeface="Times New Roman"/>
+              </a:defRPr>
+            </a:pPr>
+            <a:r>
+              <a:t>Client Edge Processing: User's web camera captures video. MediaPipe JS local library maps 33 joints (99 floats).</a:t>
+            </a:r>
+          </a:p>
+          <a:p>
+            <a:pPr>
+              <a:spcAft>
+                <a:spcPts val="800"/>
+              </a:spcAft>
+              <a:defRPr sz="1400">
+                <a:solidFill>
+                  <a:srgbClr val="1C1C1C"/>
+                </a:solidFill>
+                <a:latin typeface="Times New Roman"/>
+              </a:defRPr>
+            </a:pPr>
+            <a:r>
+              <a:t>Persistent Transport: Streams coordinates at 15-20 FPS using persistent, low-overhead HTML5 WebSockets.</a:t>
+            </a:r>
+          </a:p>
+          <a:p>
+            <a:pPr>
+              <a:spcAft>
+                <a:spcPts val="800"/>
+              </a:spcAft>
+              <a:defRPr sz="1400">
+                <a:solidFill>
+                  <a:srgbClr val="1C1C1C"/>
+                </a:solidFill>
+                <a:latin typeface="Times New Roman"/>
+              </a:defRPr>
+            </a:pPr>
+            <a:r>
+              <a:t>FastAPI Backend: Asynchronous WebSocket pipeline (/ws &amp; /ws/exercise) routes coordinate frames.</a:t>
+            </a:r>
+          </a:p>
+          <a:p>
+            <a:pPr>
+              <a:spcAft>
+                <a:spcPts val="800"/>
+              </a:spcAft>
+              <a:defRPr sz="1400">
+                <a:solidFill>
+                  <a:srgbClr val="1C1C1C"/>
+                </a:solidFill>
+                <a:latin typeface="Times New Roman"/>
+              </a:defRPr>
+            </a:pPr>
+            <a:r>
+              <a:t>In-Memory Analysis: Scikit-learn model classifies posture in &lt;1.5ms. Custom rule engines verify form metrics.</a:t>
+            </a:r>
           </a:p>
         </p:txBody>
       </p:sp>
@@ -4314,10 +4766,89 @@
           </a:xfrm>
         </p:spPr>
         <p:txBody>
-          <a:bodyPr/>
+          <a:bodyPr wrap="square"/>
           <a:lstStyle/>
           <a:p>
+            <a:pPr>
+              <a:spcAft>
+                <a:spcPts val="1600"/>
+              </a:spcAft>
+              <a:defRPr sz="2400" b="1">
+                <a:solidFill>
+                  <a:srgbClr val="E48312"/>
+                </a:solidFill>
+                <a:latin typeface="Times New Roman"/>
+              </a:defRPr>
+              <a:buNone/>
+            </a:pPr>
+            <a:r>
+              <a:t>Data Engineering Pipeline (Angle Calculations)</a:t>
+            </a:r>
             <a:endParaRPr lang="en-IN" dirty="0"/>
+          </a:p>
+          <a:p>
+            <a:pPr>
+              <a:spcAft>
+                <a:spcPts val="800"/>
+              </a:spcAft>
+              <a:defRPr sz="1400">
+                <a:solidFill>
+                  <a:srgbClr val="1C1C1C"/>
+                </a:solidFill>
+                <a:latin typeface="Times New Roman"/>
+              </a:defRPr>
+            </a:pPr>
+            <a:r>
+              <a:t>Landmark Vectorization: Transforms 33 body coordinate landmarks into a flat 99-feature float array.</a:t>
+            </a:r>
+          </a:p>
+          <a:p>
+            <a:pPr>
+              <a:spcAft>
+                <a:spcPts val="800"/>
+              </a:spcAft>
+              <a:defRPr sz="1400">
+                <a:solidFill>
+                  <a:srgbClr val="1C1C1C"/>
+                </a:solidFill>
+                <a:latin typeface="Times New Roman"/>
+              </a:defRPr>
+            </a:pPr>
+            <a:r>
+              <a:t>Pose Normalization: Scales coordinate arrays against shoulder-width to make tracking distance-independent.</a:t>
+            </a:r>
+          </a:p>
+          <a:p>
+            <a:pPr>
+              <a:spcAft>
+                <a:spcPts val="800"/>
+              </a:spcAft>
+              <a:defRPr sz="1400">
+                <a:solidFill>
+                  <a:srgbClr val="1C1C1C"/>
+                </a:solidFill>
+                <a:latin typeface="Times New Roman"/>
+              </a:defRPr>
+            </a:pPr>
+            <a:r>
+              <a:t>Neck Angle Geometry: Midpoint M = (Left + Right)/2. Vector V = Nose - M. Angle theta calculated via cos(theta) = -V_y / ||V||.</a:t>
+            </a:r>
+          </a:p>
+          <a:p>
+            <a:pPr>
+              <a:spcAft>
+                <a:spcPts val="800"/>
+              </a:spcAft>
+              <a:defRPr sz="1400">
+                <a:solidFill>
+                  <a:srgbClr val="1C1C1C"/>
+                </a:solidFill>
+                <a:latin typeface="Times New Roman"/>
+              </a:defRPr>
+            </a:pPr>
+            <a:r>
+              <a:t>Posture Rules: Lateral Neck Tilt flagged if theta &gt; 15 degrees. Shoulder Imbalance flagged if left/right height diff &gt; 0.03.</a:t>
+            </a:r>
           </a:p>
         </p:txBody>
       </p:sp>
@@ -4357,6 +4888,630 @@
         <p14:creationId xmlns:p14="http://schemas.microsoft.com/office/powerpoint/2010/main" val="2523598057"/>
       </p:ext>
     </p:extLst>
+  </p:cSld>
+  <p:clrMapOvr>
+    <a:masterClrMapping/>
+  </p:clrMapOvr>
+</p:sld>
+</file>
+
+<file path=ppt/slides/slide6.xml><?xml version="1.0" encoding="utf-8"?>
+<p:sld xmlns:a="http://schemas.openxmlformats.org/drawingml/2006/main" xmlns:p="http://schemas.openxmlformats.org/presentationml/2006/main" xmlns:r="http://schemas.openxmlformats.org/officeDocument/2006/relationships">
+  <p:cSld>
+    <p:spTree>
+      <p:nvGrpSpPr>
+        <p:cNvPr id="1" name=""/>
+        <p:cNvGrpSpPr/>
+        <p:nvPr/>
+      </p:nvGrpSpPr>
+      <p:grpSpPr/>
+      <p:sp>
+        <p:nvSpPr>
+          <p:cNvPr id="2" name="Title 1"/>
+          <p:cNvSpPr>
+            <a:spLocks noGrp="1"/>
+          </p:cNvSpPr>
+          <p:nvPr>
+            <p:ph type="title"/>
+          </p:nvPr>
+        </p:nvSpPr>
+        <p:spPr/>
+        <p:txBody>
+          <a:bodyPr/>
+          <a:lstStyle/>
+          <a:p/>
+        </p:txBody>
+      </p:sp>
+      <p:sp>
+        <p:nvSpPr>
+          <p:cNvPr id="3" name="Content Placeholder 2"/>
+          <p:cNvSpPr>
+            <a:spLocks noGrp="1"/>
+          </p:cNvSpPr>
+          <p:nvPr>
+            <p:ph idx="1"/>
+          </p:nvPr>
+        </p:nvSpPr>
+        <p:spPr/>
+        <p:txBody>
+          <a:bodyPr wrap="square"/>
+          <a:lstStyle/>
+          <a:p>
+            <a:pPr>
+              <a:spcAft>
+                <a:spcPts val="1600"/>
+              </a:spcAft>
+              <a:defRPr sz="2400" b="1">
+                <a:solidFill>
+                  <a:srgbClr val="E48312"/>
+                </a:solidFill>
+                <a:latin typeface="Times New Roman"/>
+              </a:defRPr>
+              <a:buNone/>
+            </a:pPr>
+            <a:r>
+              <a:t>Structured Database-Driven RAG Pattern</a:t>
+            </a:r>
+          </a:p>
+          <a:p>
+            <a:pPr>
+              <a:spcAft>
+                <a:spcPts val="800"/>
+              </a:spcAft>
+              <a:defRPr sz="1400">
+                <a:solidFill>
+                  <a:srgbClr val="1C1C1C"/>
+                </a:solidFill>
+                <a:latin typeface="Times New Roman"/>
+              </a:defRPr>
+            </a:pPr>
+            <a:r>
+              <a:t>Structured Telemetry Retrieval: Instead of raw documents, queries MySQL for profile stats (age, weight, goals) and posture history.</a:t>
+            </a:r>
+          </a:p>
+          <a:p>
+            <a:pPr>
+              <a:spcAft>
+                <a:spcPts val="800"/>
+              </a:spcAft>
+              <a:defRPr sz="1400">
+                <a:solidFill>
+                  <a:srgbClr val="1C1C1C"/>
+                </a:solidFill>
+                <a:latin typeface="Times New Roman"/>
+              </a:defRPr>
+            </a:pPr>
+            <a:r>
+              <a:t>Dynamic Prompt Augmentation: Telemetry data (average posture scores, specific faults) is injected into LangChain prompt templates.</a:t>
+            </a:r>
+          </a:p>
+          <a:p>
+            <a:pPr>
+              <a:spcAft>
+                <a:spcPts val="800"/>
+              </a:spcAft>
+              <a:defRPr sz="1400">
+                <a:solidFill>
+                  <a:srgbClr val="1C1C1C"/>
+                </a:solidFill>
+                <a:latin typeface="Times New Roman"/>
+              </a:defRPr>
+            </a:pPr>
+            <a:r>
+              <a:t>Gemini Generation: Custom augmented context is sent to Google Gemini (gemini-2.5-flash) to generate tailored workouts.</a:t>
+            </a:r>
+          </a:p>
+          <a:p>
+            <a:pPr>
+              <a:spcAft>
+                <a:spcPts val="800"/>
+              </a:spcAft>
+              <a:defRPr sz="1400">
+                <a:solidFill>
+                  <a:srgbClr val="1C1C1C"/>
+                </a:solidFill>
+                <a:latin typeface="Times New Roman"/>
+              </a:defRPr>
+            </a:pPr>
+            <a:r>
+              <a:t>Output Standardization: Gemini returns a structured JSON workout and diet plan, parsed directly by the backend for user display.</a:t>
+            </a:r>
+          </a:p>
+        </p:txBody>
+      </p:sp>
+      <p:pic>
+        <p:nvPicPr>
+          <p:cNvPr id="4" name="Picture 3" descr="image.png"/>
+          <p:cNvPicPr>
+            <a:picLocks noChangeAspect="1"/>
+          </p:cNvPicPr>
+          <p:nvPr/>
+        </p:nvPicPr>
+        <p:blipFill>
+          <a:blip r:embed="rId2"/>
+          <a:stretch>
+            <a:fillRect/>
+          </a:stretch>
+        </p:blipFill>
+        <p:spPr>
+          <a:xfrm>
+            <a:off x="1580457" y="210539"/>
+            <a:ext cx="9092045" cy="1158340"/>
+          </a:xfrm>
+          <a:prstGeom prst="rect">
+            <a:avLst/>
+          </a:prstGeom>
+        </p:spPr>
+      </p:pic>
+    </p:spTree>
+  </p:cSld>
+  <p:clrMapOvr>
+    <a:masterClrMapping/>
+  </p:clrMapOvr>
+</p:sld>
+</file>
+
+<file path=ppt/slides/slide7.xml><?xml version="1.0" encoding="utf-8"?>
+<p:sld xmlns:a="http://schemas.openxmlformats.org/drawingml/2006/main" xmlns:p="http://schemas.openxmlformats.org/presentationml/2006/main" xmlns:r="http://schemas.openxmlformats.org/officeDocument/2006/relationships">
+  <p:cSld>
+    <p:spTree>
+      <p:nvGrpSpPr>
+        <p:cNvPr id="1" name=""/>
+        <p:cNvGrpSpPr/>
+        <p:nvPr/>
+      </p:nvGrpSpPr>
+      <p:grpSpPr/>
+      <p:sp>
+        <p:nvSpPr>
+          <p:cNvPr id="2" name="Title 1"/>
+          <p:cNvSpPr>
+            <a:spLocks noGrp="1"/>
+          </p:cNvSpPr>
+          <p:nvPr>
+            <p:ph type="title"/>
+          </p:nvPr>
+        </p:nvSpPr>
+        <p:spPr/>
+        <p:txBody>
+          <a:bodyPr/>
+          <a:lstStyle/>
+          <a:p/>
+        </p:txBody>
+      </p:sp>
+      <p:sp>
+        <p:nvSpPr>
+          <p:cNvPr id="3" name="Content Placeholder 2"/>
+          <p:cNvSpPr>
+            <a:spLocks noGrp="1"/>
+          </p:cNvSpPr>
+          <p:nvPr>
+            <p:ph idx="1"/>
+          </p:nvPr>
+        </p:nvSpPr>
+        <p:spPr/>
+        <p:txBody>
+          <a:bodyPr wrap="square"/>
+          <a:lstStyle/>
+          <a:p>
+            <a:pPr>
+              <a:spcAft>
+                <a:spcPts val="1600"/>
+              </a:spcAft>
+              <a:defRPr sz="2400" b="1">
+                <a:solidFill>
+                  <a:srgbClr val="E48312"/>
+                </a:solidFill>
+                <a:latin typeface="Times New Roman"/>
+              </a:defRPr>
+              <a:buNone/>
+            </a:pPr>
+            <a:r>
+              <a:t>Containerization &amp; Isolation (Docker)</a:t>
+            </a:r>
+          </a:p>
+          <a:p>
+            <a:pPr>
+              <a:spcAft>
+                <a:spcPts val="800"/>
+              </a:spcAft>
+              <a:defRPr sz="1400">
+                <a:solidFill>
+                  <a:srgbClr val="1C1C1C"/>
+                </a:solidFill>
+                <a:latin typeface="Times New Roman"/>
+              </a:defRPr>
+            </a:pPr>
+            <a:r>
+              <a:t>Multi-Stage Backend Build: Dockerfile compiled using python:3.10-slim. Automatically packs OpenCV &amp; GLib OS dependencies.</a:t>
+            </a:r>
+          </a:p>
+          <a:p>
+            <a:pPr>
+              <a:spcAft>
+                <a:spcPts val="800"/>
+              </a:spcAft>
+              <a:defRPr sz="1400">
+                <a:solidFill>
+                  <a:srgbClr val="1C1C1C"/>
+                </a:solidFill>
+                <a:latin typeface="Times New Roman"/>
+              </a:defRPr>
+            </a:pPr>
+            <a:r>
+              <a:t>Frontend Static Serving: React application compiled using Node builder and served via containerized Nginx.</a:t>
+            </a:r>
+          </a:p>
+          <a:p>
+            <a:pPr>
+              <a:spcAft>
+                <a:spcPts val="800"/>
+              </a:spcAft>
+              <a:defRPr sz="1400">
+                <a:solidFill>
+                  <a:srgbClr val="1C1C1C"/>
+                </a:solidFill>
+                <a:latin typeface="Times New Roman"/>
+              </a:defRPr>
+            </a:pPr>
+            <a:r>
+              <a:t>Database Security &amp; Isolation: MySQL 8 service is containerized, restricting port 3306 exclusively to the internal Docker network.</a:t>
+            </a:r>
+          </a:p>
+          <a:p>
+            <a:pPr>
+              <a:spcAft>
+                <a:spcPts val="800"/>
+              </a:spcAft>
+              <a:defRPr sz="1400">
+                <a:solidFill>
+                  <a:srgbClr val="1C1C1C"/>
+                </a:solidFill>
+                <a:latin typeface="Times New Roman"/>
+              </a:defRPr>
+            </a:pPr>
+            <a:r>
+              <a:t>aaPanel Production Stack: Orchestrates containers, manages reverse proxy configurations, and handles SSL certificates.</a:t>
+            </a:r>
+          </a:p>
+        </p:txBody>
+      </p:sp>
+      <p:pic>
+        <p:nvPicPr>
+          <p:cNvPr id="4" name="Picture 3" descr="image.png"/>
+          <p:cNvPicPr>
+            <a:picLocks noChangeAspect="1"/>
+          </p:cNvPicPr>
+          <p:nvPr/>
+        </p:nvPicPr>
+        <p:blipFill>
+          <a:blip r:embed="rId2"/>
+          <a:stretch>
+            <a:fillRect/>
+          </a:stretch>
+        </p:blipFill>
+        <p:spPr>
+          <a:xfrm>
+            <a:off x="1580457" y="210539"/>
+            <a:ext cx="9092045" cy="1158340"/>
+          </a:xfrm>
+          <a:prstGeom prst="rect">
+            <a:avLst/>
+          </a:prstGeom>
+        </p:spPr>
+      </p:pic>
+    </p:spTree>
+  </p:cSld>
+  <p:clrMapOvr>
+    <a:masterClrMapping/>
+  </p:clrMapOvr>
+</p:sld>
+</file>
+
+<file path=ppt/slides/slide8.xml><?xml version="1.0" encoding="utf-8"?>
+<p:sld xmlns:a="http://schemas.openxmlformats.org/drawingml/2006/main" xmlns:p="http://schemas.openxmlformats.org/presentationml/2006/main" xmlns:r="http://schemas.openxmlformats.org/officeDocument/2006/relationships">
+  <p:cSld>
+    <p:spTree>
+      <p:nvGrpSpPr>
+        <p:cNvPr id="1" name=""/>
+        <p:cNvGrpSpPr/>
+        <p:nvPr/>
+      </p:nvGrpSpPr>
+      <p:grpSpPr/>
+      <p:sp>
+        <p:nvSpPr>
+          <p:cNvPr id="2" name="Title 1"/>
+          <p:cNvSpPr>
+            <a:spLocks noGrp="1"/>
+          </p:cNvSpPr>
+          <p:nvPr>
+            <p:ph type="title"/>
+          </p:nvPr>
+        </p:nvSpPr>
+        <p:spPr/>
+        <p:txBody>
+          <a:bodyPr/>
+          <a:lstStyle/>
+          <a:p/>
+        </p:txBody>
+      </p:sp>
+      <p:sp>
+        <p:nvSpPr>
+          <p:cNvPr id="3" name="Content Placeholder 2"/>
+          <p:cNvSpPr>
+            <a:spLocks noGrp="1"/>
+          </p:cNvSpPr>
+          <p:nvPr>
+            <p:ph idx="1"/>
+          </p:nvPr>
+        </p:nvSpPr>
+        <p:spPr/>
+        <p:txBody>
+          <a:bodyPr wrap="square"/>
+          <a:lstStyle/>
+          <a:p>
+            <a:pPr>
+              <a:spcAft>
+                <a:spcPts val="1600"/>
+              </a:spcAft>
+              <a:defRPr sz="2400" b="1">
+                <a:solidFill>
+                  <a:srgbClr val="E48312"/>
+                </a:solidFill>
+                <a:latin typeface="Times New Roman"/>
+              </a:defRPr>
+              <a:buNone/>
+            </a:pPr>
+            <a:r>
+              <a:t>Automated CI/CD Pipelines (GitHub Actions)</a:t>
+            </a:r>
+          </a:p>
+          <a:p>
+            <a:pPr>
+              <a:spcAft>
+                <a:spcPts val="800"/>
+              </a:spcAft>
+              <a:defRPr sz="1400">
+                <a:solidFill>
+                  <a:srgbClr val="1C1C1C"/>
+                </a:solidFill>
+                <a:latin typeface="Times New Roman"/>
+              </a:defRPr>
+            </a:pPr>
+            <a:r>
+              <a:t>Automatic Triggers: Pipeline automatically runs on every push or pull request to the main branch.</a:t>
+            </a:r>
+          </a:p>
+          <a:p>
+            <a:pPr>
+              <a:spcAft>
+                <a:spcPts val="800"/>
+              </a:spcAft>
+              <a:defRPr sz="1400">
+                <a:solidFill>
+                  <a:srgbClr val="1C1C1C"/>
+                </a:solidFill>
+                <a:latin typeface="Times New Roman"/>
+              </a:defRPr>
+            </a:pPr>
+            <a:r>
+              <a:t>Backend CI Workflow: Automatically builds Python virtual environment, lint-checks code, and runs tests using Pytest.</a:t>
+            </a:r>
+          </a:p>
+          <a:p>
+            <a:pPr>
+              <a:spcAft>
+                <a:spcPts val="800"/>
+              </a:spcAft>
+              <a:defRPr sz="1400">
+                <a:solidFill>
+                  <a:srgbClr val="1C1C1C"/>
+                </a:solidFill>
+                <a:latin typeface="Times New Roman"/>
+              </a:defRPr>
+            </a:pPr>
+            <a:r>
+              <a:t>Frontend Build Verification: Installs npm packages, checks syntax, and compiles React production assets.</a:t>
+            </a:r>
+          </a:p>
+          <a:p>
+            <a:pPr>
+              <a:spcAft>
+                <a:spcPts val="800"/>
+              </a:spcAft>
+              <a:defRPr sz="1400">
+                <a:solidFill>
+                  <a:srgbClr val="1C1C1C"/>
+                </a:solidFill>
+                <a:latin typeface="Times New Roman"/>
+              </a:defRPr>
+            </a:pPr>
+            <a:r>
+              <a:t>Container Build Verification: Compiles backend and frontend Dockerfiles to ensure deployment reliability.</a:t>
+            </a:r>
+          </a:p>
+        </p:txBody>
+      </p:sp>
+      <p:pic>
+        <p:nvPicPr>
+          <p:cNvPr id="4" name="Picture 3" descr="image.png"/>
+          <p:cNvPicPr>
+            <a:picLocks noChangeAspect="1"/>
+          </p:cNvPicPr>
+          <p:nvPr/>
+        </p:nvPicPr>
+        <p:blipFill>
+          <a:blip r:embed="rId2"/>
+          <a:stretch>
+            <a:fillRect/>
+          </a:stretch>
+        </p:blipFill>
+        <p:spPr>
+          <a:xfrm>
+            <a:off x="1580457" y="210539"/>
+            <a:ext cx="9092045" cy="1158340"/>
+          </a:xfrm>
+          <a:prstGeom prst="rect">
+            <a:avLst/>
+          </a:prstGeom>
+        </p:spPr>
+      </p:pic>
+    </p:spTree>
+  </p:cSld>
+  <p:clrMapOvr>
+    <a:masterClrMapping/>
+  </p:clrMapOvr>
+</p:sld>
+</file>
+
+<file path=ppt/slides/slide9.xml><?xml version="1.0" encoding="utf-8"?>
+<p:sld xmlns:a="http://schemas.openxmlformats.org/drawingml/2006/main" xmlns:p="http://schemas.openxmlformats.org/presentationml/2006/main" xmlns:r="http://schemas.openxmlformats.org/officeDocument/2006/relationships">
+  <p:cSld>
+    <p:spTree>
+      <p:nvGrpSpPr>
+        <p:cNvPr id="1" name=""/>
+        <p:cNvGrpSpPr/>
+        <p:nvPr/>
+      </p:nvGrpSpPr>
+      <p:grpSpPr/>
+      <p:sp>
+        <p:nvSpPr>
+          <p:cNvPr id="2" name="Title 1"/>
+          <p:cNvSpPr>
+            <a:spLocks noGrp="1"/>
+          </p:cNvSpPr>
+          <p:nvPr>
+            <p:ph type="title"/>
+          </p:nvPr>
+        </p:nvSpPr>
+        <p:spPr/>
+        <p:txBody>
+          <a:bodyPr/>
+          <a:lstStyle/>
+          <a:p/>
+        </p:txBody>
+      </p:sp>
+      <p:sp>
+        <p:nvSpPr>
+          <p:cNvPr id="3" name="Content Placeholder 2"/>
+          <p:cNvSpPr>
+            <a:spLocks noGrp="1"/>
+          </p:cNvSpPr>
+          <p:nvPr>
+            <p:ph idx="1"/>
+          </p:nvPr>
+        </p:nvSpPr>
+        <p:spPr/>
+        <p:txBody>
+          <a:bodyPr wrap="square"/>
+          <a:lstStyle/>
+          <a:p>
+            <a:pPr>
+              <a:spcAft>
+                <a:spcPts val="1600"/>
+              </a:spcAft>
+              <a:defRPr sz="2400" b="1">
+                <a:solidFill>
+                  <a:srgbClr val="E48312"/>
+                </a:solidFill>
+                <a:latin typeface="Times New Roman"/>
+              </a:defRPr>
+              <a:buNone/>
+            </a:pPr>
+            <a:r>
+              <a:t>Monitoring HUD &amp; Client Interface</a:t>
+            </a:r>
+          </a:p>
+          <a:p>
+            <a:pPr>
+              <a:spcAft>
+                <a:spcPts val="800"/>
+              </a:spcAft>
+              <a:defRPr sz="1400">
+                <a:solidFill>
+                  <a:srgbClr val="1C1C1C"/>
+                </a:solidFill>
+                <a:latin typeface="Times New Roman"/>
+              </a:defRPr>
+            </a:pPr>
+            <a:r>
+              <a:t>Real-Time Skeleton Overlay: Renders webcam feed with green (good), yellow (drift), or red (bad) skeleton landmarks.</a:t>
+            </a:r>
+          </a:p>
+          <a:p>
+            <a:pPr>
+              <a:spcAft>
+                <a:spcPts val="800"/>
+              </a:spcAft>
+              <a:defRPr sz="1400">
+                <a:solidFill>
+                  <a:srgbClr val="1C1C1C"/>
+                </a:solidFill>
+                <a:latin typeface="Times New Roman"/>
+              </a:defRPr>
+            </a:pPr>
+            <a:r>
+              <a:t>Interactive Rep HUD: Shows live rep counts, range-of-motion angles, and posture status gauges in the browser.</a:t>
+            </a:r>
+          </a:p>
+          <a:p>
+            <a:pPr>
+              <a:spcAft>
+                <a:spcPts val="800"/>
+              </a:spcAft>
+              <a:defRPr sz="1400">
+                <a:solidFill>
+                  <a:srgbClr val="1C1C1C"/>
+                </a:solidFill>
+                <a:latin typeface="Times New Roman"/>
+              </a:defRPr>
+            </a:pPr>
+            <a:r>
+              <a:t>Speech Synthesis Coaching: Client-side non-blocking audio engine calls out corrective commands like 'Sit straight'.</a:t>
+            </a:r>
+          </a:p>
+          <a:p>
+            <a:pPr>
+              <a:spcAft>
+                <a:spcPts val="800"/>
+              </a:spcAft>
+              <a:defRPr sz="1400">
+                <a:solidFill>
+                  <a:srgbClr val="1C1C1C"/>
+                </a:solidFill>
+                <a:latin typeface="Times New Roman"/>
+              </a:defRPr>
+            </a:pPr>
+            <a:r>
+              <a:t>Analytics Dashboard: Displays 14-day history, average posture scores, and tracking duration trends.</a:t>
+            </a:r>
+          </a:p>
+        </p:txBody>
+      </p:sp>
+      <p:pic>
+        <p:nvPicPr>
+          <p:cNvPr id="4" name="Picture 3" descr="image.png"/>
+          <p:cNvPicPr>
+            <a:picLocks noChangeAspect="1"/>
+          </p:cNvPicPr>
+          <p:nvPr/>
+        </p:nvPicPr>
+        <p:blipFill>
+          <a:blip r:embed="rId2"/>
+          <a:stretch>
+            <a:fillRect/>
+          </a:stretch>
+        </p:blipFill>
+        <p:spPr>
+          <a:xfrm>
+            <a:off x="1580457" y="210539"/>
+            <a:ext cx="9092045" cy="1158340"/>
+          </a:xfrm>
+          <a:prstGeom prst="rect">
+            <a:avLst/>
+          </a:prstGeom>
+        </p:spPr>
+      </p:pic>
+    </p:spTree>
   </p:cSld>
   <p:clrMapOvr>
     <a:masterClrMapping/>

</xml_diff>